<commit_message>
Harmonize slide structure for both risk monitoring rules
Both slides now share the same layout:
  LEFT:         Functional Logic (description + rationale) + Algorithm
  LEFT-BOTTOM:  Parameters table (name, value, role)
  RIGHT:        Seeded Scenario

Slide 2 (VAT Ratio):
- Removed SUSPICIOUS_COUNTRIES from parameters (already removed from code)
- Added "Role" column with detailed explanations
- Rationale folded into Functional Logic section

Slide 3 (Watchlist):
- Replaced the watchlist content table with a Parameters table
  (WATCHLIST definition + lookup type)
- Design rationale shortened and folded into Functional Logic
- Seeded Scenario now lists the three pre-configured watchlist entries
  with descriptions

Co-Authored-By: Claude Opus 4.6 (1M context) <noreply@anthropic.com>
</commit_message>
<xml_diff>
--- a/docs/risk_monitoring_rules.pptx
+++ b/docs/risk_monitoring_rules.pptx
@@ -3280,7 +3280,7 @@
         <p:spPr>
           <a:xfrm>
             <a:off x="457200" y="1005840"/>
-            <a:ext cx="5029200" cy="2286000"/>
+            <a:ext cx="5029200" cy="1463040"/>
           </a:xfrm>
           <a:prstGeom prst="rect">
             <a:avLst/>
@@ -3299,7 +3299,7 @@
               </a:spcAft>
             </a:pPr>
             <a:r>
-              <a:rPr sz="1100">
+              <a:rPr sz="1000">
                 <a:solidFill>
                   <a:srgbClr val="222222"/>
                 </a:solidFill>
@@ -3314,12 +3314,12 @@
               </a:spcAft>
             </a:pPr>
             <a:r>
-              <a:rPr sz="1100">
+              <a:rPr sz="1000">
                 <a:solidFill>
                   <a:srgbClr val="222222"/>
                 </a:solidFill>
               </a:rPr>
-              <a:t>Detects sudden shifts in a supplier's VAT-to-value ratio for a specific destination country</a:t>
+              <a:t/>
             </a:r>
           </a:p>
           <a:p>
@@ -3329,12 +3329,42 @@
               </a:spcAft>
             </a:pPr>
             <a:r>
-              <a:rPr sz="1100">
+              <a:rPr sz="1000">
                 <a:solidFill>
                   <a:srgbClr val="222222"/>
                 </a:solidFill>
               </a:rPr>
-              <a:t/>
+              <a:t>Functional Logic:</a:t>
+            </a:r>
+          </a:p>
+          <a:p>
+            <a:pPr lvl="1">
+              <a:spcAft>
+                <a:spcPts val="400"/>
+              </a:spcAft>
+            </a:pPr>
+            <a:r>
+              <a:rPr sz="1000">
+                <a:solidFill>
+                  <a:srgbClr val="222222"/>
+                </a:solidFill>
+              </a:rPr>
+              <a:t>Detects sudden shifts in a supplier's VAT-to-value ratio per destination country — a strong statistical indicator of VAT fraud.</a:t>
+            </a:r>
+          </a:p>
+          <a:p>
+            <a:pPr lvl="1">
+              <a:spcAft>
+                <a:spcPts val="400"/>
+              </a:spcAft>
+            </a:pPr>
+            <a:r>
+              <a:rPr sz="1000">
+                <a:solidFill>
+                  <a:srgbClr val="222222"/>
+                </a:solidFill>
+              </a:rPr>
+              <a:t>The check runs for all (supplier, country) pairs. Any pair whose recent ratio deviates beyond the threshold triggers a 7-day alarm.</a:t>
             </a:r>
           </a:p>
           <a:p>
@@ -3344,7 +3374,22 @@
               </a:spcAft>
             </a:pPr>
             <a:r>
-              <a:rPr sz="1100">
+              <a:rPr sz="1000">
+                <a:solidFill>
+                  <a:srgbClr val="222222"/>
+                </a:solidFill>
+              </a:rPr>
+              <a:t/>
+            </a:r>
+          </a:p>
+          <a:p>
+            <a:pPr>
+              <a:spcAft>
+                <a:spcPts val="400"/>
+              </a:spcAft>
+            </a:pPr>
+            <a:r>
+              <a:rPr sz="1000">
                 <a:solidFill>
                   <a:srgbClr val="222222"/>
                 </a:solidFill>
@@ -3359,7 +3404,7 @@
               </a:spcAft>
             </a:pPr>
             <a:r>
-              <a:rPr sz="1100">
+              <a:rPr sz="1000">
                 <a:solidFill>
                   <a:srgbClr val="222222"/>
                 </a:solidFill>
@@ -3374,7 +3419,7 @@
               </a:spcAft>
             </a:pPr>
             <a:r>
-              <a:rPr sz="1100">
+              <a:rPr sz="1000">
                 <a:solidFill>
                   <a:srgbClr val="222222"/>
                 </a:solidFill>
@@ -3389,12 +3434,12 @@
               </a:spcAft>
             </a:pPr>
             <a:r>
-              <a:rPr sz="1100">
+              <a:rPr sz="1000">
                 <a:solidFill>
                   <a:srgbClr val="222222"/>
                 </a:solidFill>
               </a:rPr>
-              <a:t>If deviation &gt; 25% of the historical ratio → raise alarm (7-day expiry)</a:t>
+              <a:t>If |current − historical| / historical &gt; 25% → raise alarm (7-day expiry)</a:t>
             </a:r>
           </a:p>
           <a:p>
@@ -3404,12 +3449,12 @@
               </a:spcAft>
             </a:pPr>
             <a:r>
-              <a:rPr sz="1100">
+              <a:rPr sz="1000">
                 <a:solidFill>
                   <a:srgbClr val="222222"/>
                 </a:solidFill>
               </a:rPr>
-              <a:t>While alarm is active, tag all new transactions from the same pair as suspicious</a:t>
+              <a:t>While alarm is active, flag all new transactions from the same pair</a:t>
             </a:r>
           </a:p>
         </p:txBody>
@@ -3423,8 +3468,8 @@
           <p:nvPr/>
         </p:nvGraphicFramePr>
         <p:xfrm>
-          <a:off x="457200" y="3474720"/>
-          <a:ext cx="5029200" cy="1600200"/>
+          <a:off x="457200" y="3383280"/>
+          <a:ext cx="5029200" cy="1280160"/>
         </p:xfrm>
         <a:graphic>
           <a:graphicData uri="http://schemas.openxmlformats.org/drawingml/2006/table">
@@ -3433,9 +3478,9 @@
                 <a:tableStyleId>{5C22544A-7EE6-4342-B048-85BDC9FD1C3A}</a:tableStyleId>
               </a:tblPr>
               <a:tblGrid>
-                <a:gridCol w="2011680"/>
-                <a:gridCol w="914400"/>
-                <a:gridCol w="2103120"/>
+                <a:gridCol w="1828800"/>
+                <a:gridCol w="731520"/>
+                <a:gridCol w="2468880"/>
               </a:tblGrid>
               <a:tr h="320040">
                 <a:tc>
@@ -3494,7 +3539,7 @@
                             <a:srgbClr val="FFFFFF"/>
                           </a:solidFill>
                         </a:rPr>
-                        <a:t>Description</a:t>
+                        <a:t>Role</a:t>
                       </a:r>
                     </a:p>
                   </a:txBody>
@@ -3554,7 +3599,7 @@
                             <a:srgbClr val="222222"/>
                           </a:solidFill>
                         </a:rPr>
-                        <a:t>Min transactions in 7-day window</a:t>
+                        <a:t>Min txns in 7-day window (prevents false positives from tiny samples)</a:t>
                       </a:r>
                     </a:p>
                   </a:txBody>
@@ -3618,7 +3663,7 @@
                             <a:srgbClr val="222222"/>
                           </a:solidFill>
                         </a:rPr>
-                        <a:t>Min transactions in 8-week baseline</a:t>
+                        <a:t>Min txns in 8-week baseline (ensures meaningful reference ratio)</a:t>
                       </a:r>
                     </a:p>
                   </a:txBody>
@@ -3678,81 +3723,13 @@
                             <a:srgbClr val="222222"/>
                           </a:solidFill>
                         </a:rPr>
-                        <a:t>Trigger threshold</a:t>
+                        <a:t>How far the 7-day ratio must deviate from baseline to trigger</a:t>
                       </a:r>
                     </a:p>
                   </a:txBody>
                   <a:tcPr/>
                 </a:tc>
               </a:tr>
-              <a:tr h="320040">
-                <a:tc>
-                  <a:txBody>
-                    <a:bodyPr/>
-                    <a:lstStyle/>
-                    <a:p>
-                      <a:pPr algn="l"/>
-                      <a:r>
-                        <a:rPr sz="1000" b="0">
-                          <a:solidFill>
-                            <a:srgbClr val="222222"/>
-                          </a:solidFill>
-                        </a:rPr>
-                        <a:t>SUSPICIOUS_COUNTRIES</a:t>
-                      </a:r>
-                    </a:p>
-                  </a:txBody>
-                  <a:tcPr>
-                    <a:solidFill>
-                      <a:srgbClr val="E8F0FA"/>
-                    </a:solidFill>
-                  </a:tcPr>
-                </a:tc>
-                <a:tc>
-                  <a:txBody>
-                    <a:bodyPr/>
-                    <a:lstStyle/>
-                    <a:p>
-                      <a:pPr algn="ctr"/>
-                      <a:r>
-                        <a:rPr sz="1000" b="0">
-                          <a:solidFill>
-                            <a:srgbClr val="222222"/>
-                          </a:solidFill>
-                        </a:rPr>
-                        <a:t>{IE}</a:t>
-                      </a:r>
-                    </a:p>
-                  </a:txBody>
-                  <a:tcPr>
-                    <a:solidFill>
-                      <a:srgbClr val="E8F0FA"/>
-                    </a:solidFill>
-                  </a:tcPr>
-                </a:tc>
-                <a:tc>
-                  <a:txBody>
-                    <a:bodyPr/>
-                    <a:lstStyle/>
-                    <a:p>
-                      <a:pPr algn="ctr"/>
-                      <a:r>
-                        <a:rPr sz="1000" b="0">
-                          <a:solidFill>
-                            <a:srgbClr val="222222"/>
-                          </a:solidFill>
-                        </a:rPr>
-                        <a:t>Countries entering suspicious queue</a:t>
-                      </a:r>
-                    </a:p>
-                  </a:txBody>
-                  <a:tcPr>
-                    <a:solidFill>
-                      <a:srgbClr val="E8F0FA"/>
-                    </a:solidFill>
-                  </a:tcPr>
-                </a:tc>
-              </a:tr>
             </a:tbl>
           </a:graphicData>
         </a:graphic>
@@ -3766,7 +3743,7 @@
         <p:spPr>
           <a:xfrm>
             <a:off x="5760720" y="1005840"/>
-            <a:ext cx="3017520" cy="2743200"/>
+            <a:ext cx="3017520" cy="3200400"/>
           </a:xfrm>
           <a:prstGeom prst="rect">
             <a:avLst/>
@@ -3905,7 +3882,7 @@
                   <a:srgbClr val="222222"/>
                 </a:solidFill>
               </a:rPr>
-              <a:t>Alarm fires on the first affected transaction.</a:t>
+              <a:t>Alarm fires on the first affected transaction. All subsequent SUP001→IE transactions are flagged for 7 days.</a:t>
             </a:r>
           </a:p>
         </p:txBody>
@@ -4013,7 +3990,7 @@
         <p:spPr>
           <a:xfrm>
             <a:off x="457200" y="1005840"/>
-            <a:ext cx="5029200" cy="1828800"/>
+            <a:ext cx="5029200" cy="1463040"/>
           </a:xfrm>
           <a:prstGeom prst="rect">
             <a:avLst/>
@@ -4032,7 +4009,7 @@
               </a:spcAft>
             </a:pPr>
             <a:r>
-              <a:rPr sz="1100">
+              <a:rPr sz="1000">
                 <a:solidFill>
                   <a:srgbClr val="222222"/>
                 </a:solidFill>
@@ -4047,12 +4024,12 @@
               </a:spcAft>
             </a:pPr>
             <a:r>
-              <a:rPr sz="1100">
+              <a:rPr sz="1000">
                 <a:solidFill>
                   <a:srgbClr val="222222"/>
                 </a:solidFill>
               </a:rPr>
-              <a:t>Flags transactions from known-suspicious supplier × country-of-origin pairs</a:t>
+              <a:t/>
             </a:r>
           </a:p>
           <a:p>
@@ -4062,12 +4039,42 @@
               </a:spcAft>
             </a:pPr>
             <a:r>
-              <a:rPr sz="1100">
+              <a:rPr sz="1000">
                 <a:solidFill>
                   <a:srgbClr val="222222"/>
                 </a:solidFill>
               </a:rPr>
-              <a:t/>
+              <a:t>Functional Logic:</a:t>
+            </a:r>
+          </a:p>
+          <a:p>
+            <a:pPr lvl="1">
+              <a:spcAft>
+                <a:spcPts val="400"/>
+              </a:spcAft>
+            </a:pPr>
+            <a:r>
+              <a:rPr sz="1000">
+                <a:solidFill>
+                  <a:srgbClr val="222222"/>
+                </a:solidFill>
+              </a:rPr>
+              <a:t>Flags transactions from known-suspicious supplier × country-of-origin pairs. Complements the statistical VAT ratio check with a rule-based intelligence layer for cases where a supplier is high-risk regardless of current VAT behaviour.</a:t>
+            </a:r>
+          </a:p>
+          <a:p>
+            <a:pPr lvl="1">
+              <a:spcAft>
+                <a:spcPts val="400"/>
+              </a:spcAft>
+            </a:pPr>
+            <a:r>
+              <a:rPr sz="1000">
+                <a:solidFill>
+                  <a:srgbClr val="222222"/>
+                </a:solidFill>
+              </a:rPr>
+              <a:t>The watchlist is editable (lib/watchlist.py) — changes take effect immediately, no restart needed.</a:t>
             </a:r>
           </a:p>
           <a:p>
@@ -4077,7 +4084,22 @@
               </a:spcAft>
             </a:pPr>
             <a:r>
-              <a:rPr sz="1100">
+              <a:rPr sz="1000">
+                <a:solidFill>
+                  <a:srgbClr val="222222"/>
+                </a:solidFill>
+              </a:rPr>
+              <a:t/>
+            </a:r>
+          </a:p>
+          <a:p>
+            <a:pPr>
+              <a:spcAft>
+                <a:spcPts val="400"/>
+              </a:spcAft>
+            </a:pPr>
+            <a:r>
+              <a:rPr sz="1000">
                 <a:solidFill>
                   <a:srgbClr val="222222"/>
                 </a:solidFill>
@@ -4092,7 +4114,7 @@
               </a:spcAft>
             </a:pPr>
             <a:r>
-              <a:rPr sz="1100">
+              <a:rPr sz="1000">
                 <a:solidFill>
                   <a:srgbClr val="222222"/>
                 </a:solidFill>
@@ -4107,7 +4129,7 @@
               </a:spcAft>
             </a:pPr>
             <a:r>
-              <a:rPr sz="1100">
+              <a:rPr sz="1000">
                 <a:solidFill>
                   <a:srgbClr val="222222"/>
                 </a:solidFill>
@@ -4122,57 +4144,12 @@
               </a:spcAft>
             </a:pPr>
             <a:r>
-              <a:rPr sz="1100">
+              <a:rPr sz="1000">
                 <a:solidFill>
                   <a:srgbClr val="222222"/>
                 </a:solidFill>
               </a:rPr>
               <a:t>If not → clear</a:t>
-            </a:r>
-          </a:p>
-          <a:p>
-            <a:pPr>
-              <a:spcAft>
-                <a:spcPts val="400"/>
-              </a:spcAft>
-            </a:pPr>
-            <a:r>
-              <a:rPr sz="1100">
-                <a:solidFill>
-                  <a:srgbClr val="222222"/>
-                </a:solidFill>
-              </a:rPr>
-              <a:t/>
-            </a:r>
-          </a:p>
-          <a:p>
-            <a:pPr>
-              <a:spcAft>
-                <a:spcPts val="400"/>
-              </a:spcAft>
-            </a:pPr>
-            <a:r>
-              <a:rPr sz="1100">
-                <a:solidFill>
-                  <a:srgbClr val="222222"/>
-                </a:solidFill>
-              </a:rPr>
-              <a:t>Simple binary lookup — no statistical analysis</a:t>
-            </a:r>
-          </a:p>
-          <a:p>
-            <a:pPr>
-              <a:spcAft>
-                <a:spcPts val="400"/>
-              </a:spcAft>
-            </a:pPr>
-            <a:r>
-              <a:rPr sz="1100">
-                <a:solidFill>
-                  <a:srgbClr val="222222"/>
-                </a:solidFill>
-              </a:rPr>
-              <a:t>Editable in lib/watchlist.py, takes effect immediately</a:t>
             </a:r>
           </a:p>
         </p:txBody>
@@ -4187,7 +4164,7 @@
         </p:nvGraphicFramePr>
         <p:xfrm>
           <a:off x="457200" y="3200400"/>
-          <a:ext cx="5029200" cy="1280160"/>
+          <a:ext cx="5029200" cy="960119"/>
         </p:xfrm>
         <a:graphic>
           <a:graphicData uri="http://schemas.openxmlformats.org/drawingml/2006/table">
@@ -4197,10 +4174,10 @@
               </a:tblPr>
               <a:tblGrid>
                 <a:gridCol w="1371600"/>
-                <a:gridCol w="914400"/>
-                <a:gridCol w="2743200"/>
+                <a:gridCol w="2286000"/>
+                <a:gridCol w="1371600"/>
               </a:tblGrid>
-              <a:tr h="320040">
+              <a:tr h="320039">
                 <a:tc>
                   <a:txBody>
                     <a:bodyPr/>
@@ -4213,7 +4190,7 @@
                             <a:srgbClr val="FFFFFF"/>
                           </a:solidFill>
                         </a:rPr>
-                        <a:t>Seller ID</a:t>
+                        <a:t>Parameter</a:t>
                       </a:r>
                     </a:p>
                   </a:txBody>
@@ -4235,7 +4212,7 @@
                             <a:srgbClr val="FFFFFF"/>
                           </a:solidFill>
                         </a:rPr>
-                        <a:t>Country</a:t>
+                        <a:t>Value</a:t>
                       </a:r>
                     </a:p>
                   </a:txBody>
@@ -4257,7 +4234,7 @@
                             <a:srgbClr val="FFFFFF"/>
                           </a:solidFill>
                         </a:rPr>
-                        <a:t>Supplier Name</a:t>
+                        <a:t>Role</a:t>
                       </a:r>
                     </a:p>
                   </a:txBody>
@@ -4268,7 +4245,7 @@
                   </a:tcPr>
                 </a:tc>
               </a:tr>
-              <a:tr h="320040">
+              <a:tr h="320039">
                 <a:tc>
                   <a:txBody>
                     <a:bodyPr/>
@@ -4281,7 +4258,7 @@
                             <a:srgbClr val="222222"/>
                           </a:solidFill>
                         </a:rPr>
-                        <a:t>SUP001</a:t>
+                        <a:t>WATCHLIST</a:t>
                       </a:r>
                     </a:p>
                   </a:txBody>
@@ -4299,7 +4276,7 @@
                             <a:srgbClr val="222222"/>
                           </a:solidFill>
                         </a:rPr>
-                        <a:t>DE</a:t>
+                        <a:t>frozenset of (seller_id, seller_country) tuples</a:t>
                       </a:r>
                     </a:p>
                   </a:txBody>
@@ -4317,14 +4294,14 @@
                             <a:srgbClr val="222222"/>
                           </a:solidFill>
                         </a:rPr>
-                        <a:t>TechZone GmbH</a:t>
+                        <a:t>Static lookup table of monitored pairs</a:t>
                       </a:r>
                     </a:p>
                   </a:txBody>
                   <a:tcPr/>
                 </a:tc>
               </a:tr>
-              <a:tr h="320040">
+              <a:tr h="320041">
                 <a:tc>
                   <a:txBody>
                     <a:bodyPr/>
@@ -4337,7 +4314,7 @@
                             <a:srgbClr val="222222"/>
                           </a:solidFill>
                         </a:rPr>
-                        <a:t>SUP002</a:t>
+                        <a:t>Lookup type</a:t>
                       </a:r>
                     </a:p>
                   </a:txBody>
@@ -4359,7 +4336,7 @@
                             <a:srgbClr val="222222"/>
                           </a:solidFill>
                         </a:rPr>
-                        <a:t>FR</a:t>
+                        <a:t>Binary (match / no match)</a:t>
                       </a:r>
                     </a:p>
                   </a:txBody>
@@ -4381,7 +4358,7 @@
                             <a:srgbClr val="222222"/>
                           </a:solidFill>
                         </a:rPr>
-                        <a:t>FashionHub Paris</a:t>
+                        <a:t>No statistical analysis — instant O(1) check</a:t>
                       </a:r>
                     </a:p>
                   </a:txBody>
@@ -4392,62 +4369,6 @@
                   </a:tcPr>
                 </a:tc>
               </a:tr>
-              <a:tr h="320040">
-                <a:tc>
-                  <a:txBody>
-                    <a:bodyPr/>
-                    <a:lstStyle/>
-                    <a:p>
-                      <a:pPr algn="l"/>
-                      <a:r>
-                        <a:rPr sz="1000" b="0">
-                          <a:solidFill>
-                            <a:srgbClr val="222222"/>
-                          </a:solidFill>
-                        </a:rPr>
-                        <a:t>SUP005</a:t>
-                      </a:r>
-                    </a:p>
-                  </a:txBody>
-                  <a:tcPr/>
-                </a:tc>
-                <a:tc>
-                  <a:txBody>
-                    <a:bodyPr/>
-                    <a:lstStyle/>
-                    <a:p>
-                      <a:pPr algn="ctr"/>
-                      <a:r>
-                        <a:rPr sz="1000" b="0">
-                          <a:solidFill>
-                            <a:srgbClr val="222222"/>
-                          </a:solidFill>
-                        </a:rPr>
-                        <a:t>NL</a:t>
-                      </a:r>
-                    </a:p>
-                  </a:txBody>
-                  <a:tcPr/>
-                </a:tc>
-                <a:tc>
-                  <a:txBody>
-                    <a:bodyPr/>
-                    <a:lstStyle/>
-                    <a:p>
-                      <a:pPr algn="ctr"/>
-                      <a:r>
-                        <a:rPr sz="1000" b="0">
-                          <a:solidFill>
-                            <a:srgbClr val="222222"/>
-                          </a:solidFill>
-                        </a:rPr>
-                        <a:t>SportsPro Amsterdam</a:t>
-                      </a:r>
-                    </a:p>
-                  </a:txBody>
-                  <a:tcPr/>
-                </a:tc>
-              </a:tr>
             </a:tbl>
           </a:graphicData>
         </a:graphic>
@@ -4461,7 +4382,7 @@
         <p:spPr>
           <a:xfrm>
             <a:off x="5760720" y="1005840"/>
-            <a:ext cx="3017520" cy="2286000"/>
+            <a:ext cx="3017520" cy="3200400"/>
           </a:xfrm>
           <a:prstGeom prst="rect">
             <a:avLst/>
@@ -4480,19 +4401,19 @@
                   <a:srgbClr val="003399"/>
                 </a:solidFill>
               </a:rPr>
-              <a:t>Design rationale</a:t>
+              <a:t>Seeded Scenario</a:t>
             </a:r>
           </a:p>
           <a:p>
             <a:pPr>
               <a:spcAft>
-                <a:spcPts val="200"/>
+                <a:spcPts val="100"/>
               </a:spcAft>
             </a:pPr>
             <a:r>
               <a:rPr sz="1000">
                 <a:solidFill>
-                  <a:srgbClr val="222222"/>
+                  <a:srgbClr val="666666"/>
                 </a:solidFill>
               </a:rPr>
               <a:t/>
@@ -4501,7 +4422,7 @@
           <a:p>
             <a:pPr>
               <a:spcAft>
-                <a:spcPts val="200"/>
+                <a:spcPts val="100"/>
               </a:spcAft>
             </a:pPr>
             <a:r>
@@ -4510,19 +4431,19 @@
                   <a:srgbClr val="222222"/>
                 </a:solidFill>
               </a:rPr>
-              <a:t>Covers scenarios where intelligence identifies a supplier as high-risk regardless of their current VAT behaviour.</a:t>
+              <a:t>Pre-configured watchlist entries:</a:t>
             </a:r>
           </a:p>
           <a:p>
             <a:pPr>
               <a:spcAft>
-                <a:spcPts val="200"/>
+                <a:spcPts val="100"/>
               </a:spcAft>
             </a:pPr>
             <a:r>
               <a:rPr sz="1000">
                 <a:solidFill>
-                  <a:srgbClr val="222222"/>
+                  <a:srgbClr val="666666"/>
                 </a:solidFill>
               </a:rPr>
               <a:t/>
@@ -4531,7 +4452,7 @@
           <a:p>
             <a:pPr>
               <a:spcAft>
-                <a:spcPts val="200"/>
+                <a:spcPts val="100"/>
               </a:spcAft>
             </a:pPr>
             <a:r>
@@ -4540,13 +4461,13 @@
                   <a:srgbClr val="222222"/>
                 </a:solidFill>
               </a:rPr>
-              <a:t>Complements the statistical VAT ratio check with a rule-based layer.</a:t>
+              <a:t>• SUP001 (DE) — TechZone GmbH</a:t>
             </a:r>
           </a:p>
           <a:p>
             <a:pPr>
               <a:spcAft>
-                <a:spcPts val="200"/>
+                <a:spcPts val="100"/>
               </a:spcAft>
             </a:pPr>
             <a:r>
@@ -4555,22 +4476,127 @@
                   <a:srgbClr val="222222"/>
                 </a:solidFill>
               </a:rPr>
-              <a:t/>
+              <a:t>   Overlaps with the VAT fraud scenario</a:t>
             </a:r>
           </a:p>
           <a:p>
             <a:pPr>
               <a:spcAft>
-                <a:spcPts val="200"/>
+                <a:spcPts val="100"/>
               </a:spcAft>
             </a:pPr>
             <a:r>
               <a:rPr sz="1000">
                 <a:solidFill>
+                  <a:srgbClr val="666666"/>
+                </a:solidFill>
+              </a:rPr>
+              <a:t/>
+            </a:r>
+          </a:p>
+          <a:p>
+            <a:pPr>
+              <a:spcAft>
+                <a:spcPts val="100"/>
+              </a:spcAft>
+            </a:pPr>
+            <a:r>
+              <a:rPr sz="1000">
+                <a:solidFill>
                   <a:srgbClr val="222222"/>
                 </a:solidFill>
               </a:rPr>
-              <a:t>Adding new entries requires no code change — just edit the WATCHLIST set.</a:t>
+              <a:t>• SUP002 (FR) — FashionHub Paris</a:t>
+            </a:r>
+          </a:p>
+          <a:p>
+            <a:pPr>
+              <a:spcAft>
+                <a:spcPts val="100"/>
+              </a:spcAft>
+            </a:pPr>
+            <a:r>
+              <a:rPr sz="1000">
+                <a:solidFill>
+                  <a:srgbClr val="222222"/>
+                </a:solidFill>
+              </a:rPr>
+              <a:t>   Known suspicious supplier</a:t>
+            </a:r>
+          </a:p>
+          <a:p>
+            <a:pPr>
+              <a:spcAft>
+                <a:spcPts val="100"/>
+              </a:spcAft>
+            </a:pPr>
+            <a:r>
+              <a:rPr sz="1000">
+                <a:solidFill>
+                  <a:srgbClr val="666666"/>
+                </a:solidFill>
+              </a:rPr>
+              <a:t/>
+            </a:r>
+          </a:p>
+          <a:p>
+            <a:pPr>
+              <a:spcAft>
+                <a:spcPts val="100"/>
+              </a:spcAft>
+            </a:pPr>
+            <a:r>
+              <a:rPr sz="1000">
+                <a:solidFill>
+                  <a:srgbClr val="222222"/>
+                </a:solidFill>
+              </a:rPr>
+              <a:t>• SUP005 (NL) — SportsPro Amsterdam</a:t>
+            </a:r>
+          </a:p>
+          <a:p>
+            <a:pPr>
+              <a:spcAft>
+                <a:spcPts val="100"/>
+              </a:spcAft>
+            </a:pPr>
+            <a:r>
+              <a:rPr sz="1000">
+                <a:solidFill>
+                  <a:srgbClr val="222222"/>
+                </a:solidFill>
+              </a:rPr>
+              <a:t>   Known suspicious supplier</a:t>
+            </a:r>
+          </a:p>
+          <a:p>
+            <a:pPr>
+              <a:spcAft>
+                <a:spcPts val="100"/>
+              </a:spcAft>
+            </a:pPr>
+            <a:r>
+              <a:rPr sz="1000">
+                <a:solidFill>
+                  <a:srgbClr val="666666"/>
+                </a:solidFill>
+              </a:rPr>
+              <a:t/>
+            </a:r>
+          </a:p>
+          <a:p>
+            <a:pPr>
+              <a:spcAft>
+                <a:spcPts val="100"/>
+              </a:spcAft>
+            </a:pPr>
+            <a:r>
+              <a:rPr sz="1000">
+                <a:solidFill>
+                  <a:srgbClr val="222222"/>
+                </a:solidFill>
+              </a:rPr>
+              <a:t>Any transaction from these (seller, country) pairs is automatically flagged.</a:t>
             </a:r>
           </a:p>
         </p:txBody>

</xml_diff>

<commit_message>
Remove fake parameters table from RT Risk Monitoring 2 slide
The watchlist has no tuneable parameters — the list itself is the
configuration, shown in the Seeded Scenario section.

Co-Authored-By: Claude Opus 4.6 (1M context) <noreply@anthropic.com>
</commit_message>
<xml_diff>
--- a/docs/risk_monitoring_rules.pptx
+++ b/docs/risk_monitoring_rules.pptx
@@ -4154,228 +4154,9 @@
           </a:p>
         </p:txBody>
       </p:sp>
-      <p:graphicFrame>
-        <p:nvGraphicFramePr>
-          <p:cNvPr id="5" name="Table 4"/>
-          <p:cNvGraphicFramePr>
-            <a:graphicFrameLocks noGrp="1"/>
-          </p:cNvGraphicFramePr>
-          <p:nvPr/>
-        </p:nvGraphicFramePr>
-        <p:xfrm>
-          <a:off x="457200" y="3200400"/>
-          <a:ext cx="5029200" cy="960119"/>
-        </p:xfrm>
-        <a:graphic>
-          <a:graphicData uri="http://schemas.openxmlformats.org/drawingml/2006/table">
-            <a:tbl>
-              <a:tblPr firstRow="1" bandRow="1">
-                <a:tableStyleId>{5C22544A-7EE6-4342-B048-85BDC9FD1C3A}</a:tableStyleId>
-              </a:tblPr>
-              <a:tblGrid>
-                <a:gridCol w="1371600"/>
-                <a:gridCol w="2286000"/>
-                <a:gridCol w="1371600"/>
-              </a:tblGrid>
-              <a:tr h="320039">
-                <a:tc>
-                  <a:txBody>
-                    <a:bodyPr/>
-                    <a:lstStyle/>
-                    <a:p>
-                      <a:pPr algn="l"/>
-                      <a:r>
-                        <a:rPr sz="1100" b="1">
-                          <a:solidFill>
-                            <a:srgbClr val="FFFFFF"/>
-                          </a:solidFill>
-                        </a:rPr>
-                        <a:t>Parameter</a:t>
-                      </a:r>
-                    </a:p>
-                  </a:txBody>
-                  <a:tcPr>
-                    <a:solidFill>
-                      <a:srgbClr val="0050A0"/>
-                    </a:solidFill>
-                  </a:tcPr>
-                </a:tc>
-                <a:tc>
-                  <a:txBody>
-                    <a:bodyPr/>
-                    <a:lstStyle/>
-                    <a:p>
-                      <a:pPr algn="ctr"/>
-                      <a:r>
-                        <a:rPr sz="1100" b="1">
-                          <a:solidFill>
-                            <a:srgbClr val="FFFFFF"/>
-                          </a:solidFill>
-                        </a:rPr>
-                        <a:t>Value</a:t>
-                      </a:r>
-                    </a:p>
-                  </a:txBody>
-                  <a:tcPr>
-                    <a:solidFill>
-                      <a:srgbClr val="0050A0"/>
-                    </a:solidFill>
-                  </a:tcPr>
-                </a:tc>
-                <a:tc>
-                  <a:txBody>
-                    <a:bodyPr/>
-                    <a:lstStyle/>
-                    <a:p>
-                      <a:pPr algn="ctr"/>
-                      <a:r>
-                        <a:rPr sz="1100" b="1">
-                          <a:solidFill>
-                            <a:srgbClr val="FFFFFF"/>
-                          </a:solidFill>
-                        </a:rPr>
-                        <a:t>Role</a:t>
-                      </a:r>
-                    </a:p>
-                  </a:txBody>
-                  <a:tcPr>
-                    <a:solidFill>
-                      <a:srgbClr val="0050A0"/>
-                    </a:solidFill>
-                  </a:tcPr>
-                </a:tc>
-              </a:tr>
-              <a:tr h="320039">
-                <a:tc>
-                  <a:txBody>
-                    <a:bodyPr/>
-                    <a:lstStyle/>
-                    <a:p>
-                      <a:pPr algn="l"/>
-                      <a:r>
-                        <a:rPr sz="1000" b="0">
-                          <a:solidFill>
-                            <a:srgbClr val="222222"/>
-                          </a:solidFill>
-                        </a:rPr>
-                        <a:t>WATCHLIST</a:t>
-                      </a:r>
-                    </a:p>
-                  </a:txBody>
-                  <a:tcPr/>
-                </a:tc>
-                <a:tc>
-                  <a:txBody>
-                    <a:bodyPr/>
-                    <a:lstStyle/>
-                    <a:p>
-                      <a:pPr algn="ctr"/>
-                      <a:r>
-                        <a:rPr sz="1000" b="0">
-                          <a:solidFill>
-                            <a:srgbClr val="222222"/>
-                          </a:solidFill>
-                        </a:rPr>
-                        <a:t>frozenset of (seller_id, seller_country) tuples</a:t>
-                      </a:r>
-                    </a:p>
-                  </a:txBody>
-                  <a:tcPr/>
-                </a:tc>
-                <a:tc>
-                  <a:txBody>
-                    <a:bodyPr/>
-                    <a:lstStyle/>
-                    <a:p>
-                      <a:pPr algn="ctr"/>
-                      <a:r>
-                        <a:rPr sz="1000" b="0">
-                          <a:solidFill>
-                            <a:srgbClr val="222222"/>
-                          </a:solidFill>
-                        </a:rPr>
-                        <a:t>Static lookup table of monitored pairs</a:t>
-                      </a:r>
-                    </a:p>
-                  </a:txBody>
-                  <a:tcPr/>
-                </a:tc>
-              </a:tr>
-              <a:tr h="320041">
-                <a:tc>
-                  <a:txBody>
-                    <a:bodyPr/>
-                    <a:lstStyle/>
-                    <a:p>
-                      <a:pPr algn="l"/>
-                      <a:r>
-                        <a:rPr sz="1000" b="0">
-                          <a:solidFill>
-                            <a:srgbClr val="222222"/>
-                          </a:solidFill>
-                        </a:rPr>
-                        <a:t>Lookup type</a:t>
-                      </a:r>
-                    </a:p>
-                  </a:txBody>
-                  <a:tcPr>
-                    <a:solidFill>
-                      <a:srgbClr val="E8F0FA"/>
-                    </a:solidFill>
-                  </a:tcPr>
-                </a:tc>
-                <a:tc>
-                  <a:txBody>
-                    <a:bodyPr/>
-                    <a:lstStyle/>
-                    <a:p>
-                      <a:pPr algn="ctr"/>
-                      <a:r>
-                        <a:rPr sz="1000" b="0">
-                          <a:solidFill>
-                            <a:srgbClr val="222222"/>
-                          </a:solidFill>
-                        </a:rPr>
-                        <a:t>Binary (match / no match)</a:t>
-                      </a:r>
-                    </a:p>
-                  </a:txBody>
-                  <a:tcPr>
-                    <a:solidFill>
-                      <a:srgbClr val="E8F0FA"/>
-                    </a:solidFill>
-                  </a:tcPr>
-                </a:tc>
-                <a:tc>
-                  <a:txBody>
-                    <a:bodyPr/>
-                    <a:lstStyle/>
-                    <a:p>
-                      <a:pPr algn="ctr"/>
-                      <a:r>
-                        <a:rPr sz="1000" b="0">
-                          <a:solidFill>
-                            <a:srgbClr val="222222"/>
-                          </a:solidFill>
-                        </a:rPr>
-                        <a:t>No statistical analysis — instant O(1) check</a:t>
-                      </a:r>
-                    </a:p>
-                  </a:txBody>
-                  <a:tcPr>
-                    <a:solidFill>
-                      <a:srgbClr val="E8F0FA"/>
-                    </a:solidFill>
-                  </a:tcPr>
-                </a:tc>
-              </a:tr>
-            </a:tbl>
-          </a:graphicData>
-        </a:graphic>
-      </p:graphicFrame>
-      <p:sp>
-        <p:nvSpPr>
-          <p:cNvPr id="6" name="TextBox 5"/>
+      <p:sp>
+        <p:nvSpPr>
+          <p:cNvPr id="5" name="TextBox 4"/>
           <p:cNvSpPr txBox="1"/>
           <p:nvPr/>
         </p:nvSpPr>

</xml_diff>